<commit_message>
Update architecture diagram — MongoDB now ACTIVE (Phase 3a), not deferred
Updated GPA_Architecture_Current_vs_Future.pptx:
- Slide 1: Phase 3a Part 1 — JWS Signatures (COMPLETE ✓)
- Slide 2: Phase 3a Part 2 — MongoDB Implementation (STARTING NOW ✓)

Changed from Phase 3b/4 (Future - Deferred) to Phase 3a (In Progress)
Removed orange TRIGGER badge — MongoDB starts immediately after signatures.

Cost: $0 (local Docker) or $50–200/mo (MongoDB Atlas)
Effort: 6–8 hours | Risk: Low
Timeline: Phase 3 Week 2-3 (Week 1: JWS done ✓)

Co-Authored-By: Claude Haiku 4.5 <noreply@anthropic.com>
</commit_message>
<xml_diff>
--- a/docs/GPA_Architecture_Current_vs_Future.pptx
+++ b/docs/GPA_Architecture_Current_vs_Future.pptx
@@ -994,7 +994,7 @@
                   <a:srgbClr val="065A82"/>
                 </a:solidFill>
               </a:rPr>
-              <a:t>GPA Architecture: Phase 3a (Current)</a:t>
+              <a:t>GPA Architecture: Phase 3a Part 1</a:t>
             </a:r>
             <a:endParaRPr lang="en-US" sz="2800" dirty="0"/>
           </a:p>
@@ -1030,7 +1030,7 @@
                   <a:srgbClr val="2C3E50"/>
                 </a:solidFill>
               </a:rPr>
-              <a:t>File-based audit trail with JWS signatures</a:t>
+              <a:t>JWS Signatures (COMPLETE ✓ 2026-06-04)</a:t>
             </a:r>
             <a:endParaRPr lang="en-US" sz="1100" dirty="0"/>
           </a:p>
@@ -1247,7 +1247,7 @@
             <a:avLst/>
           </a:prstGeom>
           <a:solidFill>
-            <a:srgbClr val="02C39A"/>
+            <a:srgbClr val="52AA5E"/>
           </a:solidFill>
           <a:ln w="25400">
             <a:solidFill>
@@ -1339,13 +1339,13 @@
         <p:spPr>
           <a:xfrm>
             <a:off x="10515600" y="1371600"/>
-            <a:ext cx="1828800" cy="914400"/>
+            <a:ext cx="1645920" cy="914400"/>
           </a:xfrm>
           <a:prstGeom prst="roundRect">
             <a:avLst/>
           </a:prstGeom>
           <a:solidFill>
-            <a:srgbClr val="52AA5E"/>
+            <a:srgbClr val="02C39A"/>
           </a:solidFill>
           <a:ln w="25400">
             <a:solidFill>
@@ -1364,7 +1364,7 @@
         <p:spPr>
           <a:xfrm>
             <a:off x="10515600" y="1737360"/>
-            <a:ext cx="1828800" cy="274320"/>
+            <a:ext cx="1645920" cy="274320"/>
           </a:xfrm>
           <a:prstGeom prst="rect">
             <a:avLst/>
@@ -1529,7 +1529,7 @@
                   <a:srgbClr val="2C3E50"/>
                 </a:solidFill>
               </a:rPr>
-              <a:t>✓ Verification: CLI tool (verify_audit_log.py)</a:t>
+              <a:t>✓ Verification: CLI tool + Python API</a:t>
             </a:r>
             <a:endParaRPr lang="en-US" sz="800" dirty="0"/>
           </a:p>
@@ -1565,7 +1565,7 @@
                   <a:srgbClr val="2C3E50"/>
                 </a:solidFill>
               </a:rPr>
-              <a:t>✓ Cost: $0 (local keys, no server)</a:t>
+              <a:t>✓ Cost: $0 (no server required)</a:t>
             </a:r>
             <a:endParaRPr lang="en-US" sz="800" dirty="0"/>
           </a:p>
@@ -1573,79 +1573,7 @@
       </p:sp>
       <p:sp>
         <p:nvSpPr>
-          <p:cNvPr id="20" name="Text 18"/>
-          <p:cNvSpPr/>
-          <p:nvPr/>
-        </p:nvSpPr>
-        <p:spPr>
-          <a:xfrm>
-            <a:off x="731520" y="4572000"/>
-            <a:ext cx="11430000" cy="320040"/>
-          </a:xfrm>
-          <a:prstGeom prst="rect">
-            <a:avLst/>
-          </a:prstGeom>
-          <a:noFill/>
-          <a:ln/>
-        </p:spPr>
-        <p:txBody>
-          <a:bodyPr wrap="square" rtlCol="0" anchor="ctr"/>
-          <a:lstStyle/>
-          <a:p>
-            <a:pPr indent="0" marL="0">
-              <a:buNone/>
-            </a:pPr>
-            <a:r>
-              <a:rPr lang="en-US" sz="800" dirty="0">
-                <a:solidFill>
-                  <a:srgbClr val="2C3E50"/>
-                </a:solidFill>
-              </a:rPr>
-              <a:t>✓ Scale: 50–200 cases/day</a:t>
-            </a:r>
-            <a:endParaRPr lang="en-US" sz="800" dirty="0"/>
-          </a:p>
-        </p:txBody>
-      </p:sp>
-      <p:sp>
-        <p:nvSpPr>
-          <p:cNvPr id="21" name="Text 19"/>
-          <p:cNvSpPr/>
-          <p:nvPr/>
-        </p:nvSpPr>
-        <p:spPr>
-          <a:xfrm>
-            <a:off x="731520" y="4937760"/>
-            <a:ext cx="11430000" cy="320040"/>
-          </a:xfrm>
-          <a:prstGeom prst="rect">
-            <a:avLst/>
-          </a:prstGeom>
-          <a:noFill/>
-          <a:ln/>
-        </p:spPr>
-        <p:txBody>
-          <a:bodyPr wrap="square" rtlCol="0" anchor="ctr"/>
-          <a:lstStyle/>
-          <a:p>
-            <a:pPr indent="0" marL="0">
-              <a:buNone/>
-            </a:pPr>
-            <a:r>
-              <a:rPr lang="en-US" sz="800" dirty="0">
-                <a:solidFill>
-                  <a:srgbClr val="2C3E50"/>
-                </a:solidFill>
-              </a:rPr>
-              <a:t>✓ Admissibility: Forensically verifiable (public key in repo)</a:t>
-            </a:r>
-            <a:endParaRPr lang="en-US" sz="800" dirty="0"/>
-          </a:p>
-        </p:txBody>
-      </p:sp>
-      <p:sp>
-        <p:nvSpPr>
-          <p:cNvPr id="22" name="Shape 20"/>
+          <p:cNvPr id="20" name="Shape 18"/>
           <p:cNvSpPr/>
           <p:nvPr/>
         </p:nvSpPr>
@@ -1658,11 +1586,11 @@
             <a:avLst/>
           </a:prstGeom>
           <a:solidFill>
-            <a:srgbClr val="F5F5F5"/>
+            <a:srgbClr val="52AA5E"/>
           </a:solidFill>
           <a:ln w="12700">
             <a:solidFill>
-              <a:srgbClr val="02C39A"/>
+              <a:srgbClr val="2C3E50"/>
             </a:solidFill>
             <a:prstDash val="solid"/>
           </a:ln>
@@ -1670,13 +1598,13 @@
       </p:sp>
       <p:sp>
         <p:nvSpPr>
-          <p:cNvPr id="23" name="Text 21"/>
-          <p:cNvSpPr/>
-          <p:nvPr/>
-        </p:nvSpPr>
-        <p:spPr>
-          <a:xfrm>
-            <a:off x="640080" y="7223760"/>
+          <p:cNvPr id="21" name="Text 19"/>
+          <p:cNvSpPr/>
+          <p:nvPr/>
+        </p:nvSpPr>
+        <p:spPr>
+          <a:xfrm>
+            <a:off x="640080" y="7315200"/>
             <a:ext cx="11978640" cy="548640"/>
           </a:xfrm>
           <a:prstGeom prst="rect">
@@ -1693,14 +1621,14 @@
               <a:buNone/>
             </a:pPr>
             <a:r>
-              <a:rPr lang="en-US" sz="800" b="1" dirty="0">
-                <a:solidFill>
-                  <a:srgbClr val="065A82"/>
-                </a:solidFill>
-              </a:rPr>
-              <a:t>✓ Write-before-emit: Audit record written to disk with JWS signature BEFORE determination returned to pipeline</a:t>
-            </a:r>
-            <a:endParaRPr lang="en-US" sz="800" dirty="0"/>
+              <a:rPr lang="en-US" sz="900" b="1" dirty="0">
+                <a:solidFill>
+                  <a:srgbClr val="FFFFFF"/>
+                </a:solidFill>
+              </a:rPr>
+              <a:t>✓ PHASE 3A WEEK 1 COMPLETE — JWS signatures deployed (commit 28bc13c)</a:t>
+            </a:r>
+            <a:endParaRPr lang="en-US" sz="900" dirty="0"/>
           </a:p>
         </p:txBody>
       </p:sp>
@@ -1766,7 +1694,7 @@
                   <a:srgbClr val="065A82"/>
                 </a:solidFill>
               </a:rPr>
-              <a:t>GPA Architecture: Phase 3b/4 (Future - Deferred)</a:t>
+              <a:t>GPA Architecture: Phase 3a Part 2 (NOW ACTIVE)</a:t>
             </a:r>
             <a:endParaRPr lang="en-US" sz="2800" dirty="0"/>
           </a:p>
@@ -1797,12 +1725,12 @@
               <a:buNone/>
             </a:pPr>
             <a:r>
-              <a:rPr lang="en-US" sz="1100" i="1" dirty="0">
-                <a:solidFill>
-                  <a:srgbClr val="2C3E50"/>
-                </a:solidFill>
-              </a:rPr>
-              <a:t>Hybrid MongoDB (online) + Signed JSONL Archive (forensic)</a:t>
+              <a:rPr lang="en-US" sz="1100" b="1" i="1" dirty="0">
+                <a:solidFill>
+                  <a:srgbClr val="02C39A"/>
+                </a:solidFill>
+              </a:rPr>
+              <a:t>MongoDB Implementation (Starting Week 2 ✓)</a:t>
             </a:r>
             <a:endParaRPr lang="en-US" sz="1100" dirty="0"/>
           </a:p>
@@ -1863,7 +1791,7 @@
                   <a:srgbClr val="FFFFFF"/>
                 </a:solidFill>
               </a:rPr>
-              <a:t>ONLINE: MongoDB Database</a:t>
+              <a:t>ONLINE: MongoDB</a:t>
             </a:r>
             <a:endParaRPr lang="en-US" sz="1100" dirty="0"/>
           </a:p>
@@ -1913,7 +1841,7 @@
                   <a:srgbClr val="FFFFFF"/>
                 </a:solidFill>
               </a:rPr>
-              <a:t>✓ Parallel writes (doc-level locks)</a:t>
+              <a:t>✓ Parallel writes</a:t>
             </a:r>
             <a:endParaRPr lang="en-US" sz="700" dirty="0"/>
           </a:p>
@@ -1941,7 +1869,7 @@
                   <a:srgbClr val="FFFFFF"/>
                 </a:solidFill>
               </a:rPr>
-              <a:t>✓ Indexed: case_id, status, created_at</a:t>
+              <a:t>✓ Indexed by case_id, status</a:t>
             </a:r>
             <a:endParaRPr lang="en-US" sz="700" dirty="0"/>
           </a:p>
@@ -1969,21 +1897,7 @@
                   <a:srgbClr val="FFFFFF"/>
                 </a:solidFill>
               </a:rPr>
-              <a:t>✓ Serves nurses/physician queues</a:t>
-            </a:r>
-            <a:endParaRPr lang="en-US" sz="700" dirty="0"/>
-          </a:p>
-          <a:p>
-            <a:pPr indent="0" marL="0">
-              <a:buNone/>
-            </a:pPr>
-            <a:r>
-              <a:rPr lang="en-US" sz="700" dirty="0">
-                <a:solidFill>
-                  <a:srgbClr val="FFFFFF"/>
-                </a:solidFill>
-              </a:rPr>
-              <a:t>✓ Option: Local Docker or MongoDB Atlas cloud</a:t>
+              <a:t>✓ Serves nursing dashboards</a:t>
             </a:r>
             <a:endParaRPr lang="en-US" sz="700" dirty="0"/>
           </a:p>
@@ -2094,7 +2008,7 @@
                   <a:srgbClr val="2C3E50"/>
                 </a:solidFill>
               </a:rPr>
-              <a:t>✓ JWS signatures (phase 3a)</a:t>
+              <a:t>✓ JWS signatures preserved</a:t>
             </a:r>
             <a:endParaRPr lang="en-US" sz="700" dirty="0"/>
           </a:p>
@@ -2136,7 +2050,7 @@
                   <a:srgbClr val="2C3E50"/>
                 </a:solidFill>
               </a:rPr>
-              <a:t>✓ Forensic evidence grade</a:t>
+              <a:t>✓ Forensic audit grade</a:t>
             </a:r>
             <a:endParaRPr lang="en-US" sz="700" dirty="0"/>
           </a:p>
@@ -2151,20 +2065,6 @@
                 </a:solidFill>
               </a:rPr>
               <a:t>✓ Verifiable offline</a:t>
-            </a:r>
-            <a:endParaRPr lang="en-US" sz="700" dirty="0"/>
-          </a:p>
-          <a:p>
-            <a:pPr indent="0" marL="0">
-              <a:buNone/>
-            </a:pPr>
-            <a:r>
-              <a:rPr lang="en-US" sz="700" dirty="0">
-                <a:solidFill>
-                  <a:srgbClr val="2C3E50"/>
-                </a:solidFill>
-              </a:rPr>
-              <a:t>✓ archive/signed_cases_*.jsonl</a:t>
             </a:r>
             <a:endParaRPr lang="en-US" sz="700" dirty="0"/>
           </a:p>
@@ -2200,7 +2100,7 @@
                   <a:srgbClr val="065A82"/>
                 </a:solidFill>
               </a:rPr>
-              <a:t>Query Flows:</a:t>
+              <a:t>Implementation (Phase 3 Week 2-3):</a:t>
             </a:r>
             <a:endParaRPr lang="en-US" sz="1100" dirty="0"/>
           </a:p>
@@ -2208,28 +2108,39 @@
       </p:sp>
       <p:sp>
         <p:nvSpPr>
-          <p:cNvPr id="11" name="Shape 9"/>
-          <p:cNvSpPr/>
-          <p:nvPr/>
-        </p:nvSpPr>
-        <p:spPr>
-          <a:xfrm>
-            <a:off x="457200" y="4526280"/>
-            <a:ext cx="5943600" cy="1005840"/>
-          </a:xfrm>
-          <a:prstGeom prst="rect">
-            <a:avLst/>
-          </a:prstGeom>
-          <a:solidFill>
-            <a:srgbClr val="F5F5F5"/>
-          </a:solidFill>
-          <a:ln w="19050">
-            <a:solidFill>
-              <a:srgbClr val="028090"/>
-            </a:solidFill>
-            <a:prstDash val="solid"/>
-          </a:ln>
-        </p:spPr>
+          <p:cNvPr id="11" name="Text 9"/>
+          <p:cNvSpPr/>
+          <p:nvPr/>
+        </p:nvSpPr>
+        <p:spPr>
+          <a:xfrm>
+            <a:off x="731520" y="4526280"/>
+            <a:ext cx="11430000" cy="274320"/>
+          </a:xfrm>
+          <a:prstGeom prst="rect">
+            <a:avLst/>
+          </a:prstGeom>
+          <a:noFill/>
+          <a:ln/>
+        </p:spPr>
+        <p:txBody>
+          <a:bodyPr wrap="square" rtlCol="0" anchor="ctr"/>
+          <a:lstStyle/>
+          <a:p>
+            <a:pPr indent="0" marL="0">
+              <a:buNone/>
+            </a:pPr>
+            <a:r>
+              <a:rPr lang="en-US" sz="750" dirty="0">
+                <a:solidFill>
+                  <a:srgbClr val="2C3E50"/>
+                </a:solidFill>
+              </a:rPr>
+              <a:t>→ persistence/mongo_client.py (CaseStore + MongoDBCaseStore)</a:t>
+            </a:r>
+            <a:endParaRPr lang="en-US" sz="750" dirty="0"/>
+          </a:p>
+        </p:txBody>
       </p:sp>
       <p:sp>
         <p:nvSpPr>
@@ -2239,8 +2150,8 @@
         </p:nvSpPr>
         <p:spPr>
           <a:xfrm>
-            <a:off x="640080" y="4663440"/>
-            <a:ext cx="5577840" cy="731520"/>
+            <a:off x="731520" y="4846320"/>
+            <a:ext cx="11430000" cy="274320"/>
           </a:xfrm>
           <a:prstGeom prst="rect">
             <a:avLst/>
@@ -2261,10 +2172,32 @@
                   <a:srgbClr val="2C3E50"/>
                 </a:solidFill>
               </a:rPr>
-              <a:t>Nurses/Dashboards: MongoDB</a:t>
+              <a:t>→ logs/bilateral_logger_mongodb.py (sign-write to MongoDB)</a:t>
             </a:r>
             <a:endParaRPr lang="en-US" sz="750" dirty="0"/>
           </a:p>
+        </p:txBody>
+      </p:sp>
+      <p:sp>
+        <p:nvSpPr>
+          <p:cNvPr id="13" name="Text 11"/>
+          <p:cNvSpPr/>
+          <p:nvPr/>
+        </p:nvSpPr>
+        <p:spPr>
+          <a:xfrm>
+            <a:off x="731520" y="5166360"/>
+            <a:ext cx="11430000" cy="274320"/>
+          </a:xfrm>
+          <a:prstGeom prst="rect">
+            <a:avLst/>
+          </a:prstGeom>
+          <a:noFill/>
+          <a:ln/>
+        </p:spPr>
+        <p:txBody>
+          <a:bodyPr wrap="square" rtlCol="0" anchor="ctr"/>
+          <a:lstStyle/>
           <a:p>
             <a:pPr indent="0" marL="0">
               <a:buNone/>
@@ -2275,10 +2208,32 @@
                   <a:srgbClr val="2C3E50"/>
                 </a:solidFill>
               </a:rPr>
-              <a:t>→ Real-time case status</a:t>
+              <a:t>→ ops/export_signed_cases.py (nightly JSONL export)</a:t>
             </a:r>
             <a:endParaRPr lang="en-US" sz="750" dirty="0"/>
           </a:p>
+        </p:txBody>
+      </p:sp>
+      <p:sp>
+        <p:nvSpPr>
+          <p:cNvPr id="14" name="Text 12"/>
+          <p:cNvSpPr/>
+          <p:nvPr/>
+        </p:nvSpPr>
+        <p:spPr>
+          <a:xfrm>
+            <a:off x="731520" y="5486400"/>
+            <a:ext cx="11430000" cy="274320"/>
+          </a:xfrm>
+          <a:prstGeom prst="rect">
+            <a:avLst/>
+          </a:prstGeom>
+          <a:noFill/>
+          <a:ln/>
+        </p:spPr>
+        <p:txBody>
+          <a:bodyPr wrap="square" rtlCol="0" anchor="ctr"/>
+          <a:lstStyle/>
           <a:p>
             <a:pPr indent="0" marL="0">
               <a:buNone/>
@@ -2289,7 +2244,7 @@
                   <a:srgbClr val="2C3E50"/>
                 </a:solidFill>
               </a:rPr>
-              <a:t>→ Fast "pending" queries</a:t>
+              <a:t>→ config/persistence.yaml (mode: jsonl ↔ mongodb)</a:t>
             </a:r>
             <a:endParaRPr lang="en-US" sz="750" dirty="0"/>
           </a:p>
@@ -2297,39 +2252,14 @@
       </p:sp>
       <p:sp>
         <p:nvSpPr>
-          <p:cNvPr id="13" name="Shape 11"/>
-          <p:cNvSpPr/>
-          <p:nvPr/>
-        </p:nvSpPr>
-        <p:spPr>
-          <a:xfrm>
-            <a:off x="6858000" y="4526280"/>
-            <a:ext cx="5943600" cy="1005840"/>
-          </a:xfrm>
-          <a:prstGeom prst="rect">
-            <a:avLst/>
-          </a:prstGeom>
-          <a:solidFill>
-            <a:srgbClr val="F5F5F5"/>
-          </a:solidFill>
-          <a:ln w="19050">
-            <a:solidFill>
-              <a:srgbClr val="52AA5E"/>
-            </a:solidFill>
-            <a:prstDash val="solid"/>
-          </a:ln>
-        </p:spPr>
-      </p:sp>
-      <p:sp>
-        <p:nvSpPr>
-          <p:cNvPr id="14" name="Text 12"/>
-          <p:cNvSpPr/>
-          <p:nvPr/>
-        </p:nvSpPr>
-        <p:spPr>
-          <a:xfrm>
-            <a:off x="7040880" y="4663440"/>
-            <a:ext cx="5577840" cy="731520"/>
+          <p:cNvPr id="15" name="Text 13"/>
+          <p:cNvSpPr/>
+          <p:nvPr/>
+        </p:nvSpPr>
+        <p:spPr>
+          <a:xfrm>
+            <a:off x="457200" y="5806440"/>
+            <a:ext cx="12344400" cy="228600"/>
           </a:xfrm>
           <a:prstGeom prst="rect">
             <a:avLst/>
@@ -2345,76 +2275,12 @@
               <a:buNone/>
             </a:pPr>
             <a:r>
-              <a:rPr lang="en-US" sz="750" dirty="0">
-                <a:solidFill>
-                  <a:srgbClr val="2C3E50"/>
-                </a:solidFill>
-              </a:rPr>
-              <a:t>Auditors/Regulators: Archive</a:t>
-            </a:r>
-            <a:endParaRPr lang="en-US" sz="750" dirty="0"/>
-          </a:p>
-          <a:p>
-            <a:pPr indent="0" marL="0">
-              <a:buNone/>
-            </a:pPr>
-            <a:r>
-              <a:rPr lang="en-US" sz="750" dirty="0">
-                <a:solidFill>
-                  <a:srgbClr val="2C3E50"/>
-                </a:solidFill>
-              </a:rPr>
-              <a:t>→ Verify audit trail</a:t>
-            </a:r>
-            <a:endParaRPr lang="en-US" sz="750" dirty="0"/>
-          </a:p>
-          <a:p>
-            <a:pPr indent="0" marL="0">
-              <a:buNone/>
-            </a:pPr>
-            <a:r>
-              <a:rPr lang="en-US" sz="750" dirty="0">
-                <a:solidFill>
-                  <a:srgbClr val="2C3E50"/>
-                </a:solidFill>
-              </a:rPr>
-              <a:t>→ Prove no tampering</a:t>
-            </a:r>
-            <a:endParaRPr lang="en-US" sz="750" dirty="0"/>
-          </a:p>
-        </p:txBody>
-      </p:sp>
-      <p:sp>
-        <p:nvSpPr>
-          <p:cNvPr id="15" name="Text 13"/>
-          <p:cNvSpPr/>
-          <p:nvPr/>
-        </p:nvSpPr>
-        <p:spPr>
-          <a:xfrm>
-            <a:off x="457200" y="5715000"/>
-            <a:ext cx="12344400" cy="228600"/>
-          </a:xfrm>
-          <a:prstGeom prst="rect">
-            <a:avLst/>
-          </a:prstGeom>
-          <a:noFill/>
-          <a:ln/>
-        </p:spPr>
-        <p:txBody>
-          <a:bodyPr wrap="square" rtlCol="0" anchor="ctr"/>
-          <a:lstStyle/>
-          <a:p>
-            <a:pPr indent="0" marL="0">
-              <a:buNone/>
-            </a:pPr>
-            <a:r>
               <a:rPr lang="en-US" sz="1100" b="1" dirty="0">
                 <a:solidFill>
                   <a:srgbClr val="065A82"/>
                 </a:solidFill>
               </a:rPr>
-              <a:t>Cost &amp; Timeline:</a:t>
+              <a:t>Cost Options:</a:t>
             </a:r>
             <a:endParaRPr lang="en-US" sz="1100" dirty="0"/>
           </a:p>
@@ -2428,8 +2294,8 @@
         </p:nvSpPr>
         <p:spPr>
           <a:xfrm>
-            <a:off x="457200" y="6035040"/>
-            <a:ext cx="2743200" cy="640080"/>
+            <a:off x="457200" y="6126480"/>
+            <a:ext cx="2926080" cy="548640"/>
           </a:xfrm>
           <a:prstGeom prst="rect">
             <a:avLst/>
@@ -2453,8 +2319,8 @@
         </p:nvSpPr>
         <p:spPr>
           <a:xfrm>
-            <a:off x="548640" y="6126480"/>
-            <a:ext cx="2560320" cy="457200"/>
+            <a:off x="640080" y="6263640"/>
+            <a:ext cx="2560320" cy="274320"/>
           </a:xfrm>
           <a:prstGeom prst="rect">
             <a:avLst/>
@@ -2470,28 +2336,14 @@
               <a:buNone/>
             </a:pPr>
             <a:r>
-              <a:rPr lang="en-US" sz="700" dirty="0">
+              <a:rPr lang="en-US" sz="800" b="1" dirty="0">
                 <a:solidFill>
                   <a:srgbClr val="2C3E50"/>
                 </a:solidFill>
               </a:rPr>
-              <a:t>Local Docker:</a:t>
-            </a:r>
-            <a:endParaRPr lang="en-US" sz="700" dirty="0"/>
-          </a:p>
-          <a:p>
-            <a:pPr algn="ctr" indent="0" marL="0">
-              <a:buNone/>
-            </a:pPr>
-            <a:r>
-              <a:rPr lang="en-US" sz="700" dirty="0">
-                <a:solidFill>
-                  <a:srgbClr val="2C3E50"/>
-                </a:solidFill>
-              </a:rPr>
-              <a:t>$0 | Easy setup</a:t>
-            </a:r>
-            <a:endParaRPr lang="en-US" sz="700" dirty="0"/>
+              <a:t>Local Docker: $0</a:t>
+            </a:r>
+            <a:endParaRPr lang="en-US" sz="800" dirty="0"/>
           </a:p>
         </p:txBody>
       </p:sp>
@@ -2503,8 +2355,8 @@
         </p:nvSpPr>
         <p:spPr>
           <a:xfrm>
-            <a:off x="3383280" y="6035040"/>
-            <a:ext cx="2743200" cy="640080"/>
+            <a:off x="3566160" y="6126480"/>
+            <a:ext cx="2926080" cy="548640"/>
           </a:xfrm>
           <a:prstGeom prst="rect">
             <a:avLst/>
@@ -2528,8 +2380,8 @@
         </p:nvSpPr>
         <p:spPr>
           <a:xfrm>
-            <a:off x="3474720" y="6126480"/>
-            <a:ext cx="2560320" cy="457200"/>
+            <a:off x="3749040" y="6263640"/>
+            <a:ext cx="2560320" cy="274320"/>
           </a:xfrm>
           <a:prstGeom prst="rect">
             <a:avLst/>
@@ -2545,49 +2397,157 @@
               <a:buNone/>
             </a:pPr>
             <a:r>
-              <a:rPr lang="en-US" sz="700" dirty="0">
+              <a:rPr lang="en-US" sz="800" b="1" dirty="0">
                 <a:solidFill>
                   <a:srgbClr val="2C3E50"/>
                 </a:solidFill>
               </a:rPr>
-              <a:t>MongoDB Atlas:</a:t>
-            </a:r>
-            <a:endParaRPr lang="en-US" sz="700" dirty="0"/>
-          </a:p>
+              <a:t>MongoDB Atlas: $50–200/mo</a:t>
+            </a:r>
+            <a:endParaRPr lang="en-US" sz="800" dirty="0"/>
+          </a:p>
+        </p:txBody>
+      </p:sp>
+      <p:sp>
+        <p:nvSpPr>
+          <p:cNvPr id="20" name="Shape 18"/>
+          <p:cNvSpPr/>
+          <p:nvPr/>
+        </p:nvSpPr>
+        <p:spPr>
+          <a:xfrm>
+            <a:off x="6675120" y="6126480"/>
+            <a:ext cx="2926080" cy="548640"/>
+          </a:xfrm>
+          <a:prstGeom prst="rect">
+            <a:avLst/>
+          </a:prstGeom>
+          <a:solidFill>
+            <a:srgbClr val="E8E8E8"/>
+          </a:solidFill>
+          <a:ln w="12700">
+            <a:solidFill>
+              <a:srgbClr val="028090"/>
+            </a:solidFill>
+            <a:prstDash val="solid"/>
+          </a:ln>
+        </p:spPr>
+      </p:sp>
+      <p:sp>
+        <p:nvSpPr>
+          <p:cNvPr id="21" name="Text 19"/>
+          <p:cNvSpPr/>
+          <p:nvPr/>
+        </p:nvSpPr>
+        <p:spPr>
+          <a:xfrm>
+            <a:off x="6858000" y="6263640"/>
+            <a:ext cx="2560320" cy="274320"/>
+          </a:xfrm>
+          <a:prstGeom prst="rect">
+            <a:avLst/>
+          </a:prstGeom>
+          <a:noFill/>
+          <a:ln/>
+        </p:spPr>
+        <p:txBody>
+          <a:bodyPr wrap="square" rtlCol="0" anchor="ctr"/>
+          <a:lstStyle/>
           <a:p>
             <a:pPr algn="ctr" indent="0" marL="0">
               <a:buNone/>
             </a:pPr>
             <a:r>
-              <a:rPr lang="en-US" sz="700" dirty="0">
+              <a:rPr lang="en-US" sz="800" b="1" dirty="0">
                 <a:solidFill>
                   <a:srgbClr val="2C3E50"/>
                 </a:solidFill>
               </a:rPr>
-              <a:t>$50–200/mo | Cloud</a:t>
-            </a:r>
-            <a:endParaRPr lang="en-US" sz="700" dirty="0"/>
-          </a:p>
-        </p:txBody>
-      </p:sp>
-      <p:sp>
-        <p:nvSpPr>
-          <p:cNvPr id="20" name="Shape 18"/>
-          <p:cNvSpPr/>
-          <p:nvPr/>
-        </p:nvSpPr>
-        <p:spPr>
-          <a:xfrm>
-            <a:off x="6309360" y="6035040"/>
-            <a:ext cx="2834640" cy="640080"/>
-          </a:xfrm>
-          <a:prstGeom prst="rect">
-            <a:avLst/>
-          </a:prstGeom>
-          <a:solidFill>
-            <a:srgbClr val="FF9500"/>
+              <a:t>Effort: 6–8 hours</a:t>
+            </a:r>
+            <a:endParaRPr lang="en-US" sz="800" dirty="0"/>
+          </a:p>
+        </p:txBody>
+      </p:sp>
+      <p:sp>
+        <p:nvSpPr>
+          <p:cNvPr id="22" name="Shape 20"/>
+          <p:cNvSpPr/>
+          <p:nvPr/>
+        </p:nvSpPr>
+        <p:spPr>
+          <a:xfrm>
+            <a:off x="9784080" y="6126480"/>
+            <a:ext cx="2926080" cy="548640"/>
+          </a:xfrm>
+          <a:prstGeom prst="rect">
+            <a:avLst/>
+          </a:prstGeom>
+          <a:solidFill>
+            <a:srgbClr val="E8E8E8"/>
           </a:solidFill>
           <a:ln w="12700">
+            <a:solidFill>
+              <a:srgbClr val="028090"/>
+            </a:solidFill>
+            <a:prstDash val="solid"/>
+          </a:ln>
+        </p:spPr>
+      </p:sp>
+      <p:sp>
+        <p:nvSpPr>
+          <p:cNvPr id="23" name="Text 21"/>
+          <p:cNvSpPr/>
+          <p:nvPr/>
+        </p:nvSpPr>
+        <p:spPr>
+          <a:xfrm>
+            <a:off x="9966960" y="6263640"/>
+            <a:ext cx="2560320" cy="274320"/>
+          </a:xfrm>
+          <a:prstGeom prst="rect">
+            <a:avLst/>
+          </a:prstGeom>
+          <a:noFill/>
+          <a:ln/>
+        </p:spPr>
+        <p:txBody>
+          <a:bodyPr wrap="square" rtlCol="0" anchor="ctr"/>
+          <a:lstStyle/>
+          <a:p>
+            <a:pPr algn="ctr" indent="0" marL="0">
+              <a:buNone/>
+            </a:pPr>
+            <a:r>
+              <a:rPr lang="en-US" sz="800" b="1" dirty="0">
+                <a:solidFill>
+                  <a:srgbClr val="2C3E50"/>
+                </a:solidFill>
+              </a:rPr>
+              <a:t>Risk: Low</a:t>
+            </a:r>
+            <a:endParaRPr lang="en-US" sz="800" dirty="0"/>
+          </a:p>
+        </p:txBody>
+      </p:sp>
+      <p:sp>
+        <p:nvSpPr>
+          <p:cNvPr id="24" name="Shape 22"/>
+          <p:cNvSpPr/>
+          <p:nvPr/>
+        </p:nvSpPr>
+        <p:spPr>
+          <a:xfrm>
+            <a:off x="457200" y="6858000"/>
+            <a:ext cx="12344400" cy="914400"/>
+          </a:xfrm>
+          <a:prstGeom prst="rect">
+            <a:avLst/>
+          </a:prstGeom>
+          <a:solidFill>
+            <a:srgbClr val="02C39A"/>
+          </a:solidFill>
+          <a:ln w="25400">
             <a:solidFill>
               <a:srgbClr val="2C3E50"/>
             </a:solidFill>
@@ -2597,14 +2557,14 @@
       </p:sp>
       <p:sp>
         <p:nvSpPr>
-          <p:cNvPr id="21" name="Text 19"/>
-          <p:cNvSpPr/>
-          <p:nvPr/>
-        </p:nvSpPr>
-        <p:spPr>
-          <a:xfrm>
-            <a:off x="6400800" y="6309360"/>
-            <a:ext cx="2651760" cy="320040"/>
+          <p:cNvPr id="25" name="Text 23"/>
+          <p:cNvSpPr/>
+          <p:nvPr/>
+        </p:nvSpPr>
+        <p:spPr>
+          <a:xfrm>
+            <a:off x="640080" y="6967728"/>
+            <a:ext cx="11978640" cy="731520"/>
           </a:xfrm>
           <a:prstGeom prst="rect">
             <a:avLst/>
@@ -2616,113 +2576,38 @@
           <a:bodyPr wrap="square" rtlCol="0" anchor="ctr"/>
           <a:lstStyle/>
           <a:p>
-            <a:pPr algn="ctr" indent="0" marL="0">
-              <a:buNone/>
-            </a:pPr>
-            <a:r>
-              <a:rPr lang="en-US" sz="700" b="1" dirty="0">
+            <a:pPr indent="0" marL="0">
+              <a:buNone/>
+            </a:pPr>
+            <a:r>
+              <a:rPr lang="en-US" sz="800" b="1" dirty="0">
                 <a:solidFill>
                   <a:srgbClr val="FFFFFF"/>
                 </a:solidFill>
               </a:rPr>
-              <a:t>TRIGGER: 100+ cases/day</a:t>
-            </a:r>
-            <a:endParaRPr lang="en-US" sz="700" dirty="0"/>
-          </a:p>
-        </p:txBody>
-      </p:sp>
-      <p:sp>
-        <p:nvSpPr>
-          <p:cNvPr id="22" name="Shape 20"/>
-          <p:cNvSpPr/>
-          <p:nvPr/>
-        </p:nvSpPr>
-        <p:spPr>
-          <a:xfrm>
-            <a:off x="457200" y="6858000"/>
-            <a:ext cx="12344400" cy="914400"/>
-          </a:xfrm>
-          <a:prstGeom prst="rect">
-            <a:avLst/>
-          </a:prstGeom>
-          <a:solidFill>
-            <a:srgbClr val="F5F5F5"/>
-          </a:solidFill>
-          <a:ln w="19050">
-            <a:solidFill>
-              <a:srgbClr val="02C39A"/>
-            </a:solidFill>
-            <a:prstDash val="solid"/>
-          </a:ln>
-        </p:spPr>
-      </p:sp>
-      <p:sp>
-        <p:nvSpPr>
-          <p:cNvPr id="23" name="Text 21"/>
-          <p:cNvSpPr/>
-          <p:nvPr/>
-        </p:nvSpPr>
-        <p:spPr>
-          <a:xfrm>
-            <a:off x="640080" y="6949440"/>
-            <a:ext cx="11978640" cy="731520"/>
-          </a:xfrm>
-          <a:prstGeom prst="rect">
-            <a:avLst/>
-          </a:prstGeom>
-          <a:noFill/>
-          <a:ln/>
-        </p:spPr>
-        <p:txBody>
-          <a:bodyPr wrap="square" rtlCol="0" anchor="ctr"/>
-          <a:lstStyle/>
+              <a:t>✓ USER APPROVAL: MongoDB moved from Phase 3b/4 (deferred) to Phase 3a (ACTIVE NOW)</a:t>
+            </a:r>
+            <a:endParaRPr lang="en-US" sz="800" dirty="0"/>
+          </a:p>
           <a:p>
             <a:pPr indent="0" marL="0">
               <a:buNone/>
             </a:pPr>
-            <a:r>
-              <a:rPr lang="en-US" sz="700" b="1" dirty="0">
-                <a:solidFill>
-                  <a:srgbClr val="065A82"/>
-                </a:solidFill>
-              </a:rPr>
-              <a:t>STATUS: MongoDB is IN SCOPE for Phase 3b/4, DEFERRED from Phase 3a</a:t>
-            </a:r>
-            <a:endParaRPr lang="en-US" sz="700" dirty="0"/>
+            <a:endParaRPr lang="en-US" sz="800" dirty="0"/>
           </a:p>
           <a:p>
             <a:pPr indent="0" marL="0">
               <a:buNone/>
             </a:pPr>
-            <a:endParaRPr lang="en-US" sz="700" dirty="0"/>
-          </a:p>
-          <a:p>
-            <a:pPr indent="0" marL="0">
-              <a:buNone/>
-            </a:pPr>
-            <a:r>
-              <a:rPr lang="en-US" sz="700" b="1" dirty="0">
-                <a:solidFill>
-                  <a:srgbClr val="065A82"/>
-                </a:solidFill>
-              </a:rPr>
-              <a:t>✓ Currently (Phase 3a): JSONL + JWS signatures work fine for pilot volume (50–200 cases/day)</a:t>
-            </a:r>
-            <a:endParaRPr lang="en-US" sz="700" dirty="0"/>
-          </a:p>
-          <a:p>
-            <a:pPr indent="0" marL="0">
-              <a:buNone/>
-            </a:pPr>
-            <a:r>
-              <a:rPr lang="en-US" sz="700" b="1" dirty="0">
-                <a:solidFill>
-                  <a:srgbClr val="065A82"/>
-                </a:solidFill>
-              </a:rPr>
-              <a:t>⏳ When pilot hits 100+: Evaluate MongoDB based on real performance data</a:t>
-            </a:r>
-            <a:endParaRPr lang="en-US" sz="700" dirty="0"/>
+            <a:r>
+              <a:rPr lang="en-US" sz="800" b="1" dirty="0">
+                <a:solidFill>
+                  <a:srgbClr val="FFFFFF"/>
+                </a:solidFill>
+              </a:rPr>
+              <a:t>Starts immediately after JWS signatures (Week 2-3). Hybrid architecture preserves forensic admissibility.</a:t>
+            </a:r>
+            <a:endParaRPr lang="en-US" sz="800" dirty="0"/>
           </a:p>
         </p:txBody>
       </p:sp>

</xml_diff>